<commit_message>
Tighten Azure challenge examples and assets
</commit_message>
<xml_diff>
--- a/course-materials/challenges/cloud/azure-segmented-service-deployment-challenge/assets/Azure Segmented Service Deployment Challenge SUBMISSION TEMPLATE.pptx
+++ b/course-materials/challenges/cloud/azure-segmented-service-deployment-challenge/assets/Azure Segmented Service Deployment Challenge SUBMISSION TEMPLATE.pptx
@@ -7457,70 +7457,30 @@
           <a:lstStyle/>
           <a:p>
             <a:r>
-              <a:rPr b="1" sz="1600">
-                <a:solidFill>
-                  <a:srgbClr val="282828"/>
-                </a:solidFill>
-              </a:rPr>
               <a:t>Must show:</a:t>
             </a:r>
           </a:p>
           <a:p>
-            <a:pPr>
-              <a:defRPr sz="1200">
-                <a:solidFill>
-                  <a:srgbClr val="373737"/>
-                </a:solidFill>
-              </a:defRPr>
-            </a:pPr>
             <a:r>
               <a:t>• resource group name is visible</a:t>
             </a:r>
           </a:p>
           <a:p>
-            <a:pPr>
-              <a:defRPr sz="1200">
-                <a:solidFill>
-                  <a:srgbClr val="373737"/>
-                </a:solidFill>
-              </a:defRPr>
-            </a:pPr>
             <a:r>
               <a:t>• both VM names are visible in the resource list</a:t>
             </a:r>
           </a:p>
           <a:p>
-            <a:pPr>
-              <a:defRPr sz="1200">
-                <a:solidFill>
-                  <a:srgbClr val="373737"/>
-                </a:solidFill>
-              </a:defRPr>
-            </a:pPr>
             <a:r>
-              <a:t>• the VNet and the server NSG are visible in the resource list</a:t>
+              <a:t>• the VNet is visible in the resource list</a:t>
             </a:r>
           </a:p>
           <a:p>
-            <a:pPr>
-              <a:defRPr sz="1200">
-                <a:solidFill>
-                  <a:srgbClr val="373737"/>
-                </a:solidFill>
-              </a:defRPr>
-            </a:pPr>
             <a:r>
               <a:t>• the Azure Resource Group Overview page is the active view</a:t>
             </a:r>
           </a:p>
           <a:p>
-            <a:pPr algn="r">
-              <a:defRPr sz="1100" i="1">
-                <a:solidFill>
-                  <a:srgbClr val="5A5A5A"/>
-                </a:solidFill>
-              </a:defRPr>
-            </a:pPr>
             <a:r>
               <a:t>One screenshot only on this slide.</a:t>
             </a:r>

</xml_diff>